<commit_message>
docs: widen quality-metrics table Source column (slide 21)
Source cells were wrapping to three lines and breaking mid-word
("decisions.m/d", "bench/resul/ts/cost-h100"). Widened colW to
[1.45, 1.35, 0.8] and shortened Source text so every cell fits two
lines with no mid-word breaks. Value column text unchanged.
</commit_message>
<xml_diff>
--- a/docs/pitch/provenance-architecture-deck.pptx
+++ b/docs/pitch/provenance-architecture-deck.pptx
@@ -13084,9 +13084,9 @@
             <a:tbl>
               <a:tblPr/>
               <a:tblGrid>
-                <a:gridCol w="1417320"/>
+                <a:gridCol w="1325880"/>
                 <a:gridCol w="1234440"/>
-                <a:gridCol w="640080"/>
+                <a:gridCol w="731520"/>
               </a:tblGrid>
               <a:tr h="0">
                 <a:tc>
@@ -13442,7 +13442,7 @@
                           <a:ea typeface="Calibri" pitchFamily="34" charset="-122"/>
                           <a:cs typeface="Calibri" pitchFamily="34" charset="-120"/>
                         </a:rPr>
-                        <a:t>uv run pytest -q</a:t>
+                        <a:t>pytest, this run</a:t>
                       </a:r>
                       <a:endParaRPr lang="en-US" sz="730" dirty="0">
                         <a:latin typeface="Calibri" charset="0"/>
@@ -13639,7 +13639,7 @@
                           <a:ea typeface="Calibri" pitchFamily="34" charset="-122"/>
                           <a:cs typeface="Calibri" pitchFamily="34" charset="-120"/>
                         </a:rPr>
-                        <a:t>go build &amp;&amp; go vet &amp;&amp; go test</a:t>
+                        <a:t>go test, this run</a:t>
                       </a:r>
                       <a:endParaRPr lang="en-US" sz="730" dirty="0">
                         <a:latin typeface="Calibri" charset="0"/>
@@ -13836,7 +13836,7 @@
                           <a:ea typeface="Calibri" pitchFamily="34" charset="-122"/>
                           <a:cs typeface="Calibri" pitchFamily="34" charset="-120"/>
                         </a:rPr>
-                        <a:t>decisions.md, STATE.md</a:t>
+                        <a:t>decisions.md</a:t>
                       </a:r>
                       <a:endParaRPr lang="en-US" sz="730" dirty="0">
                         <a:latin typeface="Calibri" charset="0"/>
@@ -14033,7 +14033,7 @@
                           <a:ea typeface="Calibri" pitchFamily="34" charset="-122"/>
                           <a:cs typeface="Calibri" pitchFamily="34" charset="-120"/>
                         </a:rPr>
-                        <a:t>ADR-012, CI run #15</a:t>
+                        <a:t>ADR-012, run #15</a:t>
                       </a:r>
                       <a:endParaRPr lang="en-US" sz="730" dirty="0">
                         <a:latin typeface="Calibri" charset="0"/>
@@ -14230,7 +14230,7 @@
                           <a:ea typeface="Calibri" pitchFamily="34" charset="-122"/>
                           <a:cs typeface="Calibri" pitchFamily="34" charset="-120"/>
                         </a:rPr>
-                        <a:t>ADR-012, CI run #15</a:t>
+                        <a:t>ADR-012, run #15</a:t>
                       </a:r>
                       <a:endParaRPr lang="en-US" sz="730" dirty="0">
                         <a:latin typeface="Calibri" charset="0"/>
@@ -14624,7 +14624,7 @@
                           <a:ea typeface="Calibri" pitchFamily="34" charset="-122"/>
                           <a:cs typeface="Calibri" pitchFamily="34" charset="-120"/>
                         </a:rPr>
-                        <a:t>bench/results/cost-h100</a:t>
+                        <a:t>bench/results</a:t>
                       </a:r>
                       <a:endParaRPr lang="en-US" sz="730" dirty="0">
                         <a:latin typeface="Calibri" charset="0"/>

</xml_diff>